<commit_message>
feat(cli): rename binary to pptd, update project URLs to open-pptd, and align skill descriptions
</commit_message>
<xml_diff>
--- a/example/starter/starter.pptx
+++ b/example/starter/starter.pptx
@@ -543,9 +543,9 @@
                   <a:srgbClr val="2563EB">
                   </a:srgbClr>
                 </a:solidFill>
-                <a:latin typeface="思源黑体"/>
-                <a:ea typeface="Microsoft YaHei"/>
-                <a:cs typeface="思源黑体"/>
+                <a:latin typeface="Georgia"/>
+                <a:ea typeface="SimSun"/>
+                <a:cs typeface="Georgia"/>
               </a:rPr>
               <a:t>核心优势矩阵</a:t>
             </a:r>
@@ -825,9 +825,9 @@
                             <a:srgbClr val="2563EB">
                             </a:srgbClr>
                           </a:solidFill>
-                          <a:latin typeface="思源黑体"/>
-                          <a:ea typeface="Microsoft YaHei"/>
-                          <a:cs typeface="思源黑体"/>
+                          <a:latin typeface="Georgia"/>
+                          <a:ea typeface="SimSun"/>
+                          <a:cs typeface="Georgia"/>
                         </a:rPr>
                         <a:t>指标维度</a:t>
                       </a:r>
@@ -884,9 +884,9 @@
                             <a:srgbClr val="2563EB">
                             </a:srgbClr>
                           </a:solidFill>
-                          <a:latin typeface="思源黑体"/>
-                          <a:ea typeface="Microsoft YaHei"/>
-                          <a:cs typeface="思源黑体"/>
+                          <a:latin typeface="Georgia"/>
+                          <a:ea typeface="SimSun"/>
+                          <a:cs typeface="Georgia"/>
                         </a:rPr>
                         <a:t>传统方案</a:t>
                       </a:r>
@@ -943,9 +943,9 @@
                             <a:srgbClr val="2563EB">
                             </a:srgbClr>
                           </a:solidFill>
-                          <a:latin typeface="思源黑体"/>
-                          <a:ea typeface="Microsoft YaHei"/>
-                          <a:cs typeface="思源黑体"/>
+                          <a:latin typeface="Georgia"/>
+                          <a:ea typeface="SimSun"/>
+                          <a:cs typeface="Georgia"/>
                         </a:rPr>
                         <a:t>PPTD 方案</a:t>
                       </a:r>
@@ -1004,9 +1004,9 @@
                             <a:srgbClr val="000000">
                             </a:srgbClr>
                           </a:solidFill>
-                          <a:latin typeface="思源黑体"/>
-                          <a:ea typeface="Microsoft YaHei"/>
-                          <a:cs typeface="思源黑体"/>
+                          <a:latin typeface="Georgia"/>
+                          <a:ea typeface="SimSun"/>
+                          <a:cs typeface="Georgia"/>
                         </a:rPr>
                         <a:t>依赖项</a:t>
                       </a:r>
@@ -1059,9 +1059,9 @@
                             <a:srgbClr val="000000">
                             </a:srgbClr>
                           </a:solidFill>
-                          <a:latin typeface="思源黑体"/>
-                          <a:ea typeface="Microsoft YaHei"/>
-                          <a:cs typeface="思源黑体"/>
+                          <a:latin typeface="Georgia"/>
+                          <a:ea typeface="SimSun"/>
+                          <a:cs typeface="Georgia"/>
                         </a:rPr>
                         <a:t>无头浏览器 / Node</a:t>
                       </a:r>
@@ -1114,9 +1114,9 @@
                             <a:srgbClr val="000000">
                             </a:srgbClr>
                           </a:solidFill>
-                          <a:latin typeface="思源黑体"/>
-                          <a:ea typeface="Microsoft YaHei"/>
-                          <a:cs typeface="思源黑体"/>
+                          <a:latin typeface="Georgia"/>
+                          <a:ea typeface="SimSun"/>
+                          <a:cs typeface="Georgia"/>
                         </a:rPr>
                         <a:t>单二进制文件</a:t>
                       </a:r>
@@ -1171,9 +1171,9 @@
                             <a:srgbClr val="000000">
                             </a:srgbClr>
                           </a:solidFill>
-                          <a:latin typeface="思源黑体"/>
-                          <a:ea typeface="Microsoft YaHei"/>
-                          <a:cs typeface="思源黑体"/>
+                          <a:latin typeface="Georgia"/>
+                          <a:ea typeface="SimSun"/>
+                          <a:cs typeface="Georgia"/>
                         </a:rPr>
                         <a:t>构建耗时</a:t>
                       </a:r>
@@ -1226,9 +1226,9 @@
                             <a:srgbClr val="000000">
                             </a:srgbClr>
                           </a:solidFill>
-                          <a:latin typeface="思源黑体"/>
-                          <a:ea typeface="Microsoft YaHei"/>
-                          <a:cs typeface="思源黑体"/>
+                          <a:latin typeface="Georgia"/>
+                          <a:ea typeface="SimSun"/>
+                          <a:cs typeface="Georgia"/>
                         </a:rPr>
                         <a:t>5 ~ 15 秒</a:t>
                       </a:r>
@@ -1281,9 +1281,9 @@
                             <a:srgbClr val="000000">
                             </a:srgbClr>
                           </a:solidFill>
-                          <a:latin typeface="思源黑体"/>
-                          <a:ea typeface="Microsoft YaHei"/>
-                          <a:cs typeface="思源黑体"/>
+                          <a:latin typeface="Georgia"/>
+                          <a:ea typeface="SimSun"/>
+                          <a:cs typeface="Georgia"/>
                         </a:rPr>
                         <a:t>&lt; 0.05 秒</a:t>
                       </a:r>
@@ -1338,9 +1338,9 @@
                             <a:srgbClr val="000000">
                             </a:srgbClr>
                           </a:solidFill>
-                          <a:latin typeface="思源黑体"/>
-                          <a:ea typeface="Microsoft YaHei"/>
-                          <a:cs typeface="思源黑体"/>
+                          <a:latin typeface="Georgia"/>
+                          <a:ea typeface="SimSun"/>
+                          <a:cs typeface="Georgia"/>
                         </a:rPr>
                         <a:t>二次编辑</a:t>
                       </a:r>
@@ -1393,9 +1393,9 @@
                             <a:srgbClr val="000000">
                             </a:srgbClr>
                           </a:solidFill>
-                          <a:latin typeface="思源黑体"/>
-                          <a:ea typeface="Microsoft YaHei"/>
-                          <a:cs typeface="思源黑体"/>
+                          <a:latin typeface="Georgia"/>
+                          <a:ea typeface="SimSun"/>
+                          <a:cs typeface="Georgia"/>
                         </a:rPr>
                         <a:t>容易错位</a:t>
                       </a:r>
@@ -1448,9 +1448,9 @@
                             <a:srgbClr val="000000">
                             </a:srgbClr>
                           </a:solidFill>
-                          <a:latin typeface="思源黑体"/>
-                          <a:ea typeface="Microsoft YaHei"/>
-                          <a:cs typeface="思源黑体"/>
+                          <a:latin typeface="Georgia"/>
+                          <a:ea typeface="SimSun"/>
+                          <a:cs typeface="Georgia"/>
                         </a:rPr>
                         <a:t>完美支持</a:t>
                       </a:r>
@@ -1620,13 +1620,13 @@
         <a:srgbClr val="1E293B"/>
       </a:dk1>
       <a:lt1>
-        <a:srgbClr val="64748B"/>
+        <a:srgbClr val="E2E8F0"/>
       </a:lt1>
       <a:dk2>
-        <a:srgbClr val="F8FAFC"/>
+        <a:srgbClr val="64748B"/>
       </a:dk2>
       <a:lt2>
-        <a:srgbClr val="E2E8F0"/>
+        <a:srgbClr val="F8FAFC"/>
       </a:lt2>
       <a:accent1>
         <a:srgbClr val="2563EB"/>
@@ -1655,17 +1655,17 @@
     </a:clrScheme>
     <a:fontScheme name="SlideForge">
       <a:majorFont>
-        <a:latin typeface="思源黑体"/>
-        <a:ea typeface="Microsoft YaHei"/>
-        <a:cs typeface="思源黑体"/>
-        <a:font script="Hans" typeface="Microsoft YaHei"/>
+        <a:latin typeface="Georgia"/>
+        <a:ea typeface="SimSun"/>
+        <a:cs typeface="Georgia"/>
+        <a:font script="Hans" typeface="SimSun"/>
         <a:font script="Hant" typeface="Microsoft JhengHei"/>
       </a:majorFont>
       <a:minorFont>
-        <a:latin typeface="思源黑体"/>
-        <a:ea typeface="Microsoft YaHei"/>
-        <a:cs typeface="思源黑体"/>
-        <a:font script="Hans" typeface="Microsoft YaHei"/>
+        <a:latin typeface="Georgia"/>
+        <a:ea typeface="SimSun"/>
+        <a:cs typeface="Georgia"/>
+        <a:font script="Hans" typeface="SimSun"/>
         <a:font script="Hant" typeface="Microsoft JhengHei"/>
       </a:minorFont>
     </a:fontScheme>

</xml_diff>